<commit_message>
v.1.5.5: Language Settings - Fase 3
- data for spanish, english and valencian
- Language Settings finished
</commit_message>
<xml_diff>
--- a/data/memories/memory_01/locales/es/documents/presentations/Presentation OLD.pptx
+++ b/data/memories/memory_01/locales/es/documents/presentations/Presentation OLD.pptx
@@ -3109,7 +3109,7 @@
           <a:lstStyle/>
           <a:p>
             <a:r>
-              <a:t>Quarterly Review</a:t>
+              <a:t>Revisión trimestral</a:t>
             </a:r>
           </a:p>
         </p:txBody>
@@ -3133,7 +3133,7 @@
               <a:defRPr sz="2200"/>
             </a:pPr>
             <a:r>
-              <a:t>Internal management presentation.</a:t>
+              <a:t>Presentación de gestión interna.</a:t>
             </a:r>
           </a:p>
           <a:p>
@@ -3141,7 +3141,7 @@
               <a:defRPr sz="2200"/>
             </a:pPr>
             <a:r>
-              <a:t>Prepared for quarterly operational review.</a:t>
+              <a:t>Preparado para revisión operativa trimestral.</a:t>
             </a:r>
           </a:p>
           <a:p>
@@ -3149,7 +3149,7 @@
               <a:defRPr sz="2200"/>
             </a:pPr>
             <a:r>
-              <a:t>Draft version - not approved for distribution.</a:t>
+              <a:t>Versión borrador: no aprobada para distribución.</a:t>
             </a:r>
           </a:p>
         </p:txBody>
@@ -3188,7 +3188,7 @@
           <a:lstStyle/>
           <a:p>
             <a:r>
-              <a:t>Agenda</a:t>
+              <a:t>Orden del día</a:t>
             </a:r>
           </a:p>
         </p:txBody>
@@ -3212,7 +3212,7 @@
               <a:defRPr sz="2200"/>
             </a:pPr>
             <a:r>
-              <a:t>Financial performance.</a:t>
+              <a:t>Desempeño financiero.</a:t>
             </a:r>
           </a:p>
           <a:p>
@@ -3220,7 +3220,7 @@
               <a:defRPr sz="2200"/>
             </a:pPr>
             <a:r>
-              <a:t>Operational changes.</a:t>
+              <a:t>Cambios operativos.</a:t>
             </a:r>
           </a:p>
           <a:p>
@@ -3228,7 +3228,7 @@
               <a:defRPr sz="2200"/>
             </a:pPr>
             <a:r>
-              <a:t>Archive project status.</a:t>
+              <a:t>Archivar el estado del proyecto.</a:t>
             </a:r>
           </a:p>
           <a:p>
@@ -3236,7 +3236,7 @@
               <a:defRPr sz="2200"/>
             </a:pPr>
             <a:r>
-              <a:t>Organisation review.</a:t>
+              <a:t>Revisión de la organización.</a:t>
             </a:r>
           </a:p>
           <a:p>
@@ -3244,7 +3244,7 @@
               <a:defRPr sz="2200"/>
             </a:pPr>
             <a:r>
-              <a:t>Pending documentation issues.</a:t>
+              <a:t>Temas de documentación pendientes.</a:t>
             </a:r>
           </a:p>
         </p:txBody>
@@ -3283,7 +3283,7 @@
           <a:lstStyle/>
           <a:p>
             <a:r>
-              <a:t>Financial Overview</a:t>
+              <a:t>Resumen financiero</a:t>
             </a:r>
           </a:p>
         </p:txBody>
@@ -3307,7 +3307,7 @@
               <a:defRPr sz="2200"/>
             </a:pPr>
             <a:r>
-              <a:t>Overall budget performance remains within expected limits.</a:t>
+              <a:t>La ejecución general del presupuesto se mantiene dentro de los límites esperados.</a:t>
             </a:r>
           </a:p>
           <a:p>
@@ -3315,7 +3315,7 @@
               <a:defRPr sz="2200"/>
             </a:pPr>
             <a:r>
-              <a:t>Some operational areas exceeded initial estimates.</a:t>
+              <a:t>Algunas áreas operativas superaron las estimaciones iniciales.</a:t>
             </a:r>
           </a:p>
           <a:p>
@@ -3323,7 +3323,7 @@
               <a:defRPr sz="2200"/>
             </a:pPr>
             <a:r>
-              <a:t>Archive-related costs increased due to additional review requirements.</a:t>
+              <a:t>Los costos relacionados con los archivos aumentaron debido a requisitos de revisión adicionales.</a:t>
             </a:r>
           </a:p>
         </p:txBody>
@@ -3362,7 +3362,7 @@
           <a:lstStyle/>
           <a:p>
             <a:r>
-              <a:t>Archive Project</a:t>
+              <a:t>Proyecto de archivo</a:t>
             </a:r>
           </a:p>
         </p:txBody>
@@ -3386,7 +3386,7 @@
               <a:defRPr sz="2200"/>
             </a:pPr>
             <a:r>
-              <a:t>Digitisation process started successfully.</a:t>
+              <a:t>El proceso de digitalización comenzó con éxito.</a:t>
             </a:r>
           </a:p>
           <a:p>
@@ -3394,7 +3394,7 @@
               <a:defRPr sz="2200"/>
             </a:pPr>
             <a:r>
-              <a:t>Historical documentation requires additional classification.</a:t>
+              <a:t>La documentación histórica requiere una clasificación adicional.</a:t>
             </a:r>
           </a:p>
           <a:p>
@@ -3402,7 +3402,7 @@
               <a:defRPr sz="2200"/>
             </a:pPr>
             <a:r>
-              <a:t>Several records do not match current organisational structures.</a:t>
+              <a:t>Varios registros no coinciden con las estructuras organizativas actuales.</a:t>
             </a:r>
           </a:p>
           <a:p>
@@ -3410,7 +3410,7 @@
               <a:defRPr sz="2200"/>
             </a:pPr>
             <a:r>
-              <a:t>Further review recommended before disposal decisions.</a:t>
+              <a:t>Se recomienda una revisión adicional antes de tomar decisiones sobre su eliminación.</a:t>
             </a:r>
           </a:p>
         </p:txBody>
@@ -3449,7 +3449,7 @@
           <a:lstStyle/>
           <a:p>
             <a:r>
-              <a:t>Organisation Changes</a:t>
+              <a:t>Cambios de organización</a:t>
             </a:r>
           </a:p>
         </p:txBody>
@@ -3473,7 +3473,7 @@
               <a:defRPr sz="2200"/>
             </a:pPr>
             <a:r>
-              <a:t>Department responsibilities have been updated.</a:t>
+              <a:t>Se han actualizado las responsabilidades del departamento.</a:t>
             </a:r>
           </a:p>
           <a:p>
@@ -3481,7 +3481,7 @@
               <a:defRPr sz="2200"/>
             </a:pPr>
             <a:r>
-              <a:t>Previous structures remain available in archived documentation.</a:t>
+              <a:t>Las estructuras anteriores permanecen disponibles en la documentación archivada.</a:t>
             </a:r>
           </a:p>
           <a:p>
@@ -3489,7 +3489,7 @@
               <a:defRPr sz="2200"/>
             </a:pPr>
             <a:r>
-              <a:t>Historical references should be preserved.</a:t>
+              <a:t>Deben preservarse las referencias históricas.</a:t>
             </a:r>
           </a:p>
         </p:txBody>
@@ -3528,7 +3528,7 @@
           <a:lstStyle/>
           <a:p>
             <a:r>
-              <a:t>Open Questions</a:t>
+              <a:t>Preguntas abiertas</a:t>
             </a:r>
           </a:p>
         </p:txBody>
@@ -3552,7 +3552,7 @@
               <a:defRPr sz="2200"/>
             </a:pPr>
             <a:r>
-              <a:t>Employee registry differences.</a:t>
+              <a:t>Diferencias en el registro de empleados.</a:t>
             </a:r>
           </a:p>
           <a:p>
@@ -3560,7 +3560,7 @@
               <a:defRPr sz="2200"/>
             </a:pPr>
             <a:r>
-              <a:t>Historical department references.</a:t>
+              <a:t>Referencias históricas del departamento.</a:t>
             </a:r>
           </a:p>
           <a:p>
@@ -3568,7 +3568,7 @@
               <a:defRPr sz="2200"/>
             </a:pPr>
             <a:r>
-              <a:t>Unclassified archive material.</a:t>
+              <a:t>Material de archivo no clasificado.</a:t>
             </a:r>
           </a:p>
           <a:p>
@@ -3576,7 +3576,7 @@
               <a:defRPr sz="2200"/>
             </a:pPr>
             <a:r>
-              <a:t>Pending management decisions.</a:t>
+              <a:t>Decisiones de gestión pendientes.</a:t>
             </a:r>
           </a:p>
         </p:txBody>

</xml_diff>